<commit_message>
sd-07-009: the lesson and deck say the figure now draws both banks
Co-Authored-By: Claude Opus 5.5 <noreply@anthropic.com>
Claude-Session: https://claude.ai/code/session_01TDEQZkTojRsEuCWxmNaEbL
</commit_message>
<xml_diff>
--- a/system-design-101/vi/lessons/sd-07-009/slides/sd-07-009.pptx
+++ b/system-design-101/vi/lessons/sd-07-009/slides/sd-07-009.pptx
@@ -2339,6 +2339,17 @@
               <a:buNone/>
             </a:pPr>
             <a:r>
+              <a:rPr lang="en-US" sz="2100" b="1" dirty="0" spc="-5" kern="0">
+                <a:solidFill>
+                  <a:srgbClr val="FFB454"/>
+                </a:solidFill>
+                <a:latin typeface="Be Vietnam Pro" pitchFamily="34" charset="0"/>
+                <a:ea typeface="Be Vietnam Pro" pitchFamily="34" charset="-122"/>
+                <a:cs typeface="Be Vietnam Pro" pitchFamily="34" charset="-120"/>
+              </a:rPr>
+              <a:t>Ngân</a:t>
+            </a:r>
+            <a:r>
               <a:rPr lang="en-US" sz="2100" b="1" dirty="0" spc="-3" kern="0">
                 <a:solidFill>
                   <a:srgbClr val="FFB454"/>
@@ -2347,7 +2358,7 @@
                 <a:ea typeface="Be Vietnam Pro" pitchFamily="34" charset="-122"/>
                 <a:cs typeface="Be Vietnam Pro" pitchFamily="34" charset="-120"/>
               </a:rPr>
-              <a:t>Alice</a:t>
+              <a:t> hàng của Alice</a:t>
             </a:r>
             <a:endParaRPr lang="en-US" sz="2100" dirty="0"/>
           </a:p>
@@ -10484,7 +10495,7 @@
               <a:buNone/>
             </a:pPr>
             <a:r>
-              <a:rPr lang="en-US" sz="1950" dirty="0" spc="5" kern="0">
+              <a:rPr lang="en-US" sz="1950" dirty="0" spc="0" kern="0">
                 <a:solidFill>
                   <a:srgbClr val="6B6A66"/>
                 </a:solidFill>
@@ -10492,7 +10503,106 @@
                 <a:ea typeface="Be Vietnam Pro" pitchFamily="34" charset="-122"/>
                 <a:cs typeface="Be Vietnam Pro" pitchFamily="34" charset="-120"/>
               </a:rPr>
-              <a:t>Bước</a:t>
+              <a:t>Hình</a:t>
+            </a:r>
+            <a:r>
+              <a:rPr lang="en-US" sz="1950" dirty="0" spc="-14" kern="0">
+                <a:solidFill>
+                  <a:srgbClr val="6B6A66"/>
+                </a:solidFill>
+                <a:latin typeface="Be Vietnam Pro" pitchFamily="34" charset="0"/>
+                <a:ea typeface="Be Vietnam Pro" pitchFamily="34" charset="-122"/>
+                <a:cs typeface="Be Vietnam Pro" pitchFamily="34" charset="-120"/>
+              </a:rPr>
+              <a:t> vẽ</a:t>
+            </a:r>
+            <a:r>
+              <a:rPr lang="en-US" sz="1950" dirty="0" spc="-3" kern="0">
+                <a:solidFill>
+                  <a:srgbClr val="6B6A66"/>
+                </a:solidFill>
+                <a:latin typeface="Be Vietnam Pro" pitchFamily="34" charset="0"/>
+                <a:ea typeface="Be Vietnam Pro" pitchFamily="34" charset="-122"/>
+                <a:cs typeface="Be Vietnam Pro" pitchFamily="34" charset="-120"/>
+              </a:rPr>
+              <a:t> cả</a:t>
+            </a:r>
+            <a:r>
+              <a:rPr lang="en-US" sz="1950" dirty="0" spc="1" kern="0">
+                <a:solidFill>
+                  <a:srgbClr val="6B6A66"/>
+                </a:solidFill>
+                <a:latin typeface="Be Vietnam Pro" pitchFamily="34" charset="0"/>
+                <a:ea typeface="Be Vietnam Pro" pitchFamily="34" charset="-122"/>
+                <a:cs typeface="Be Vietnam Pro" pitchFamily="34" charset="-120"/>
+              </a:rPr>
+              <a:t> hai</a:t>
+            </a:r>
+            <a:r>
+              <a:rPr lang="en-US" sz="1950" dirty="0" spc="-6" kern="0">
+                <a:solidFill>
+                  <a:srgbClr val="6B6A66"/>
+                </a:solidFill>
+                <a:latin typeface="Be Vietnam Pro" pitchFamily="34" charset="0"/>
+                <a:ea typeface="Be Vietnam Pro" pitchFamily="34" charset="-122"/>
+                <a:cs typeface="Be Vietnam Pro" pitchFamily="34" charset="-120"/>
+              </a:rPr>
+              <a:t> ngân</a:t>
+            </a:r>
+            <a:r>
+              <a:rPr lang="en-US" sz="1950" dirty="0" spc="1" kern="0">
+                <a:solidFill>
+                  <a:srgbClr val="6B6A66"/>
+                </a:solidFill>
+                <a:latin typeface="Be Vietnam Pro" pitchFamily="34" charset="0"/>
+                <a:ea typeface="Be Vietnam Pro" pitchFamily="34" charset="-122"/>
+                <a:cs typeface="Be Vietnam Pro" pitchFamily="34" charset="-120"/>
+              </a:rPr>
+              <a:t> hàng;</a:t>
+            </a:r>
+            <a:r>
+              <a:rPr lang="en-US" sz="1950" dirty="0" spc="3" kern="0">
+                <a:solidFill>
+                  <a:srgbClr val="6B6A66"/>
+                </a:solidFill>
+                <a:latin typeface="Be Vietnam Pro" pitchFamily="34" charset="0"/>
+                <a:ea typeface="Be Vietnam Pro" pitchFamily="34" charset="-122"/>
+                <a:cs typeface="Be Vietnam Pro" pitchFamily="34" charset="-120"/>
+              </a:rPr>
+              <a:t> bước</a:t>
+            </a:r>
+            <a:r>
+              <a:rPr lang="en-US" sz="1950" dirty="0" spc="22" kern="0">
+                <a:solidFill>
+                  <a:srgbClr val="6B6A66"/>
+                </a:solidFill>
+                <a:latin typeface="Be Vietnam Pro" pitchFamily="34" charset="0"/>
+                <a:ea typeface="Be Vietnam Pro" pitchFamily="34" charset="-122"/>
+                <a:cs typeface="Be Vietnam Pro" pitchFamily="34" charset="-120"/>
+              </a:rPr>
+              <a:t> ứng</a:t>
+            </a:r>
+            <a:r>
+              <a:rPr lang="en-US" sz="1950" dirty="0" spc="1" kern="0">
+                <a:solidFill>
+                  <a:srgbClr val="6B6A66"/>
+                </a:solidFill>
+                <a:latin typeface="Be Vietnam Pro" pitchFamily="34" charset="0"/>
+                <a:ea typeface="Be Vietnam Pro" pitchFamily="34" charset="-122"/>
+                <a:cs typeface="Be Vietnam Pro" pitchFamily="34" charset="-120"/>
+              </a:rPr>
+              <a:t> dụng</a:t>
+            </a:r>
+            <a:r>
+              <a:rPr lang="en-US" sz="1950" dirty="0" spc="34" kern="0">
+                <a:solidFill>
+                  <a:srgbClr val="6B6A66"/>
+                </a:solidFill>
+                <a:latin typeface="Be Vietnam Pro" pitchFamily="34" charset="0"/>
+                <a:ea typeface="Be Vietnam Pro" pitchFamily="34" charset="-122"/>
+                <a:cs typeface="Be Vietnam Pro" pitchFamily="34" charset="-120"/>
+              </a:rPr>
+              <a:t> gửi</a:t>
             </a:r>
             <a:r>
               <a:rPr lang="en-US" sz="1950" dirty="0" spc="0" kern="0">
@@ -10503,10 +10613,10 @@
                 <a:ea typeface="Be Vietnam Pro" pitchFamily="34" charset="-122"/>
                 <a:cs typeface="Be Vietnam Pro" pitchFamily="34" charset="-120"/>
               </a:rPr>
-              <a:t> trừ</a:t>
-            </a:r>
-            <a:r>
-              <a:rPr lang="en-US" sz="1950" dirty="0" spc="1" kern="0">
+              <a:t> lệnh</a:t>
+            </a:r>
+            <a:r>
+              <a:rPr lang="en-US" sz="1950" dirty="0" spc="-15" kern="0">
                 <a:solidFill>
                   <a:srgbClr val="6B6A66"/>
                 </a:solidFill>
@@ -10514,7 +10624,7 @@
                 <a:ea typeface="Be Vietnam Pro" pitchFamily="34" charset="-122"/>
                 <a:cs typeface="Be Vietnam Pro" pitchFamily="34" charset="-120"/>
               </a:rPr>
-              <a:t> tiền</a:t>
+              <a:t> và</a:t>
             </a:r>
             <a:r>
               <a:rPr lang="en-US" sz="1950" dirty="0" spc="-3" kern="0">
@@ -10525,10 +10635,10 @@
                 <a:ea typeface="Be Vietnam Pro" pitchFamily="34" charset="-122"/>
                 <a:cs typeface="Be Vietnam Pro" pitchFamily="34" charset="-120"/>
               </a:rPr>
-              <a:t> ở</a:t>
-            </a:r>
-            <a:r>
-              <a:rPr lang="en-US" sz="1950" dirty="0" spc="-6" kern="0">
+              <a:t> báo</a:t>
+            </a:r>
+            <a:r>
+              <a:rPr lang="en-US" sz="1950" dirty="0" spc="-1" kern="0">
                 <a:solidFill>
                   <a:srgbClr val="6B6A66"/>
                 </a:solidFill>
@@ -10536,10 +10646,10 @@
                 <a:ea typeface="Be Vietnam Pro" pitchFamily="34" charset="-122"/>
                 <a:cs typeface="Be Vietnam Pro" pitchFamily="34" charset="-120"/>
               </a:rPr>
-              <a:t> ngân</a:t>
-            </a:r>
-            <a:r>
-              <a:rPr lang="en-US" sz="1950" dirty="0" spc="1" kern="0">
+              <a:t> thành</a:t>
+            </a:r>
+            <a:r>
+              <a:rPr lang="en-US" sz="1950" dirty="0" spc="0" kern="0">
                 <a:solidFill>
                   <a:srgbClr val="6B6A66"/>
                 </a:solidFill>
@@ -10547,10 +10657,10 @@
                 <a:ea typeface="Be Vietnam Pro" pitchFamily="34" charset="-122"/>
                 <a:cs typeface="Be Vietnam Pro" pitchFamily="34" charset="-120"/>
               </a:rPr>
-              <a:t> hàng</a:t>
-            </a:r>
-            <a:r>
-              <a:rPr lang="en-US" sz="1950" dirty="0" spc="0" kern="0">
+              <a:t> công</a:t>
+            </a:r>
+            <a:r>
+              <a:rPr lang="en-US" sz="1950" dirty="0" spc="-1" kern="0">
                 <a:solidFill>
                   <a:srgbClr val="6B6A66"/>
                 </a:solidFill>
@@ -10558,10 +10668,10 @@
                 <a:ea typeface="Be Vietnam Pro" pitchFamily="34" charset="-122"/>
                 <a:cs typeface="Be Vietnam Pro" pitchFamily="34" charset="-120"/>
               </a:rPr>
-              <a:t> của</a:t>
-            </a:r>
-            <a:r>
-              <a:rPr lang="en-US" sz="1950" dirty="0" spc="-1" kern="0">
+              <a:t> chỉ</a:t>
+            </a:r>
+            <a:r>
+              <a:rPr lang="en-US" sz="1950" dirty="0" spc="-4" kern="0">
                 <a:solidFill>
                   <a:srgbClr val="6B6A66"/>
                 </a:solidFill>
@@ -10569,10 +10679,10 @@
                 <a:ea typeface="Be Vietnam Pro" pitchFamily="34" charset="-122"/>
                 <a:cs typeface="Be Vietnam Pro" pitchFamily="34" charset="-120"/>
               </a:rPr>
-              <a:t> Alice</a:t>
-            </a:r>
-            <a:r>
-              <a:rPr lang="en-US" sz="1950" dirty="0" spc="-3" kern="0">
+              <a:t> có</a:t>
+            </a:r>
+            <a:r>
+              <a:rPr lang="en-US" sz="1950" dirty="0" spc="-11" kern="0">
                 <a:solidFill>
                   <a:srgbClr val="6B6A66"/>
                 </a:solidFill>
@@ -10580,10 +10690,10 @@
                 <a:ea typeface="Be Vietnam Pro" pitchFamily="34" charset="-122"/>
                 <a:cs typeface="Be Vietnam Pro" pitchFamily="34" charset="-120"/>
               </a:rPr>
-              <a:t> có</a:t>
-            </a:r>
-            <a:r>
-              <a:rPr lang="en-US" sz="1950" dirty="0" spc="-11" kern="0">
+              <a:t> trong</a:t>
+            </a:r>
+            <a:r>
+              <a:rPr lang="en-US" sz="1950" dirty="0" spc="-2" kern="0">
                 <a:solidFill>
                   <a:srgbClr val="6B6A66"/>
                 </a:solidFill>
@@ -10591,51 +10701,7 @@
                 <a:ea typeface="Be Vietnam Pro" pitchFamily="34" charset="-122"/>
                 <a:cs typeface="Be Vietnam Pro" pitchFamily="34" charset="-120"/>
               </a:rPr>
-              <a:t> trong</a:t>
-            </a:r>
-            <a:r>
-              <a:rPr lang="en-US" sz="1950" dirty="0" spc="-1" kern="0">
-                <a:solidFill>
-                  <a:srgbClr val="6B6A66"/>
-                </a:solidFill>
-                <a:latin typeface="Be Vietnam Pro" pitchFamily="34" charset="0"/>
-                <a:ea typeface="Be Vietnam Pro" pitchFamily="34" charset="-122"/>
-                <a:cs typeface="Be Vietnam Pro" pitchFamily="34" charset="-120"/>
-              </a:rPr>
-              <a:t> chữ,</a:t>
-            </a:r>
-            <a:r>
-              <a:rPr lang="en-US" sz="1950" dirty="0" spc="0" kern="0">
-                <a:solidFill>
-                  <a:srgbClr val="6B6A66"/>
-                </a:solidFill>
-                <a:latin typeface="Be Vietnam Pro" pitchFamily="34" charset="0"/>
-                <a:ea typeface="Be Vietnam Pro" pitchFamily="34" charset="-122"/>
-                <a:cs typeface="Be Vietnam Pro" pitchFamily="34" charset="-120"/>
-              </a:rPr>
-              <a:t> không</a:t>
-            </a:r>
-            <a:r>
-              <a:rPr lang="en-US" sz="1950" dirty="0" spc="-14" kern="0">
-                <a:solidFill>
-                  <a:srgbClr val="6B6A66"/>
-                </a:solidFill>
-                <a:latin typeface="Be Vietnam Pro" pitchFamily="34" charset="0"/>
-                <a:ea typeface="Be Vietnam Pro" pitchFamily="34" charset="-122"/>
-                <a:cs typeface="Be Vietnam Pro" pitchFamily="34" charset="-120"/>
-              </a:rPr>
-              <a:t> vẽ</a:t>
-            </a:r>
-            <a:r>
-              <a:rPr lang="en-US" sz="1950" dirty="0" spc="6" kern="0">
-                <a:solidFill>
-                  <a:srgbClr val="6B6A66"/>
-                </a:solidFill>
-                <a:latin typeface="Be Vietnam Pro" pitchFamily="34" charset="0"/>
-                <a:ea typeface="Be Vietnam Pro" pitchFamily="34" charset="-122"/>
-                <a:cs typeface="Be Vietnam Pro" pitchFamily="34" charset="-120"/>
-              </a:rPr>
-              <a:t> riêng.</a:t>
+              <a:t> chữ.</a:t>
             </a:r>
             <a:endParaRPr lang="en-US" sz="1950" dirty="0"/>
           </a:p>

</xml_diff>